<commit_message>
Opdateret Parser class UML. Opdateret powerpoint. Lavet et UML over state diagram funktion
</commit_message>
<xml_diff>
--- a/Parseropgave.pptx
+++ b/Parseropgave.pptx
@@ -10,11 +10,12 @@
     <p:sldId id="259" r:id="rId4"/>
     <p:sldId id="263" r:id="rId5"/>
     <p:sldId id="258" r:id="rId6"/>
-    <p:sldId id="264" r:id="rId7"/>
-    <p:sldId id="260" r:id="rId8"/>
-    <p:sldId id="261" r:id="rId9"/>
-    <p:sldId id="265" r:id="rId10"/>
-    <p:sldId id="262" r:id="rId11"/>
+    <p:sldId id="260" r:id="rId7"/>
+    <p:sldId id="261" r:id="rId8"/>
+    <p:sldId id="262" r:id="rId9"/>
+    <p:sldId id="266" r:id="rId10"/>
+    <p:sldId id="264" r:id="rId11"/>
+    <p:sldId id="265" r:id="rId12"/>
   </p:sldIdLst>
   <p:sldSz cx="12192000" cy="6858000"/>
   <p:notesSz cx="6858000" cy="9144000"/>
@@ -113,6 +114,11 @@
       </a:defRPr>
     </a:lvl9pPr>
   </p:defaultTextStyle>
+  <p:extLst>
+    <p:ext uri="{EFAFB233-063F-42B5-8137-9DF3F51BA10A}">
+      <p15:sldGuideLst xmlns:p15="http://schemas.microsoft.com/office/powerpoint/2012/main"/>
+    </p:ext>
+  </p:extLst>
 </p:presentation>
 </file>
 
@@ -263,7 +269,7 @@
           <a:p>
             <a:fld id="{E7D51573-EB70-4F91-8888-E4C8DDA9E69C}" type="datetimeFigureOut">
               <a:rPr lang="da-DK" smtClean="0"/>
-              <a:t>23-09-2026</a:t>
+              <a:t>24-09-2026</a:t>
             </a:fld>
             <a:endParaRPr lang="da-DK"/>
           </a:p>
@@ -461,7 +467,7 @@
           <a:p>
             <a:fld id="{E7D51573-EB70-4F91-8888-E4C8DDA9E69C}" type="datetimeFigureOut">
               <a:rPr lang="da-DK" smtClean="0"/>
-              <a:t>23-09-2026</a:t>
+              <a:t>24-09-2026</a:t>
             </a:fld>
             <a:endParaRPr lang="da-DK"/>
           </a:p>
@@ -669,7 +675,7 @@
           <a:p>
             <a:fld id="{E7D51573-EB70-4F91-8888-E4C8DDA9E69C}" type="datetimeFigureOut">
               <a:rPr lang="da-DK" smtClean="0"/>
-              <a:t>23-09-2026</a:t>
+              <a:t>24-09-2026</a:t>
             </a:fld>
             <a:endParaRPr lang="da-DK"/>
           </a:p>
@@ -867,7 +873,7 @@
           <a:p>
             <a:fld id="{E7D51573-EB70-4F91-8888-E4C8DDA9E69C}" type="datetimeFigureOut">
               <a:rPr lang="da-DK" smtClean="0"/>
-              <a:t>23-09-2026</a:t>
+              <a:t>24-09-2026</a:t>
             </a:fld>
             <a:endParaRPr lang="da-DK"/>
           </a:p>
@@ -1142,7 +1148,7 @@
           <a:p>
             <a:fld id="{E7D51573-EB70-4F91-8888-E4C8DDA9E69C}" type="datetimeFigureOut">
               <a:rPr lang="da-DK" smtClean="0"/>
-              <a:t>23-09-2026</a:t>
+              <a:t>24-09-2026</a:t>
             </a:fld>
             <a:endParaRPr lang="da-DK"/>
           </a:p>
@@ -1407,7 +1413,7 @@
           <a:p>
             <a:fld id="{E7D51573-EB70-4F91-8888-E4C8DDA9E69C}" type="datetimeFigureOut">
               <a:rPr lang="da-DK" smtClean="0"/>
-              <a:t>23-09-2026</a:t>
+              <a:t>24-09-2026</a:t>
             </a:fld>
             <a:endParaRPr lang="da-DK"/>
           </a:p>
@@ -1819,7 +1825,7 @@
           <a:p>
             <a:fld id="{E7D51573-EB70-4F91-8888-E4C8DDA9E69C}" type="datetimeFigureOut">
               <a:rPr lang="da-DK" smtClean="0"/>
-              <a:t>23-09-2026</a:t>
+              <a:t>24-09-2026</a:t>
             </a:fld>
             <a:endParaRPr lang="da-DK"/>
           </a:p>
@@ -1960,7 +1966,7 @@
           <a:p>
             <a:fld id="{E7D51573-EB70-4F91-8888-E4C8DDA9E69C}" type="datetimeFigureOut">
               <a:rPr lang="da-DK" smtClean="0"/>
-              <a:t>23-09-2026</a:t>
+              <a:t>24-09-2026</a:t>
             </a:fld>
             <a:endParaRPr lang="da-DK"/>
           </a:p>
@@ -2073,7 +2079,7 @@
           <a:p>
             <a:fld id="{E7D51573-EB70-4F91-8888-E4C8DDA9E69C}" type="datetimeFigureOut">
               <a:rPr lang="da-DK" smtClean="0"/>
-              <a:t>23-09-2026</a:t>
+              <a:t>24-09-2026</a:t>
             </a:fld>
             <a:endParaRPr lang="da-DK"/>
           </a:p>
@@ -2384,7 +2390,7 @@
           <a:p>
             <a:fld id="{E7D51573-EB70-4F91-8888-E4C8DDA9E69C}" type="datetimeFigureOut">
               <a:rPr lang="da-DK" smtClean="0"/>
-              <a:t>23-09-2026</a:t>
+              <a:t>24-09-2026</a:t>
             </a:fld>
             <a:endParaRPr lang="da-DK"/>
           </a:p>
@@ -2672,7 +2678,7 @@
           <a:p>
             <a:fld id="{E7D51573-EB70-4F91-8888-E4C8DDA9E69C}" type="datetimeFigureOut">
               <a:rPr lang="da-DK" smtClean="0"/>
-              <a:t>23-09-2026</a:t>
+              <a:t>24-09-2026</a:t>
             </a:fld>
             <a:endParaRPr lang="da-DK"/>
           </a:p>
@@ -2913,7 +2919,7 @@
           <a:p>
             <a:fld id="{E7D51573-EB70-4F91-8888-E4C8DDA9E69C}" type="datetimeFigureOut">
               <a:rPr lang="da-DK" smtClean="0"/>
-              <a:t>23-09-2026</a:t>
+              <a:t>24-09-2026</a:t>
             </a:fld>
             <a:endParaRPr lang="da-DK"/>
           </a:p>
@@ -3742,7 +3748,7 @@
           <p:cNvPr id="2" name="Titel 1">
             <a:extLst>
               <a:ext uri="{FF2B5EF4-FFF2-40B4-BE49-F238E27FC236}">
-                <a16:creationId xmlns:a16="http://schemas.microsoft.com/office/drawing/2014/main" id="{DCA28694-89F1-88F1-5355-980347DBFAA4}"/>
+                <a16:creationId xmlns:a16="http://schemas.microsoft.com/office/drawing/2014/main" id="{2BA640CE-B359-C502-D5FE-2C086BD26106}"/>
               </a:ext>
             </a:extLst>
           </p:cNvPr>
@@ -3760,7 +3766,7 @@
           <a:p>
             <a:r>
               <a:rPr lang="da-DK" dirty="0"/>
-              <a:t>Hvis jeg havde mere tid</a:t>
+              <a:t>Ekstra slide: Særlige funktioner</a:t>
             </a:r>
           </a:p>
         </p:txBody>
@@ -3770,7 +3776,7 @@
           <p:cNvPr id="3" name="Pladsholder til indhold 2">
             <a:extLst>
               <a:ext uri="{FF2B5EF4-FFF2-40B4-BE49-F238E27FC236}">
-                <a16:creationId xmlns:a16="http://schemas.microsoft.com/office/drawing/2014/main" id="{F1220C65-72A9-26FD-CFBC-EE52A711C2AD}"/>
+                <a16:creationId xmlns:a16="http://schemas.microsoft.com/office/drawing/2014/main" id="{A4C80449-42F7-02F3-176C-58786BAD9DCE}"/>
               </a:ext>
             </a:extLst>
           </p:cNvPr>
@@ -3781,34 +3787,284 @@
             <p:ph idx="1"/>
           </p:nvPr>
         </p:nvSpPr>
-        <p:spPr/>
-        <p:txBody>
-          <a:bodyPr/>
-          <a:lstStyle/>
-          <a:p>
-            <a:r>
-              <a:rPr lang="da-DK" dirty="0"/>
-              <a:t>Lave JSON formatering selv uden pakken JSON</a:t>
-            </a:r>
-          </a:p>
-          <a:p>
-            <a:r>
-              <a:rPr lang="da-DK" dirty="0"/>
-              <a:t>Lave bedre brugerinterface. Så brugeren bliver spurgt.</a:t>
-            </a:r>
-          </a:p>
-          <a:p>
-            <a:r>
-              <a:rPr lang="da-DK" dirty="0"/>
-              <a:t>Håndtere at kunne rette simple fejl selv. Eksempelvis trykfejl.</a:t>
-            </a:r>
-          </a:p>
-        </p:txBody>
-      </p:sp>
+        <p:spPr>
+          <a:xfrm>
+            <a:off x="838200" y="1331849"/>
+            <a:ext cx="10515600" cy="4351338"/>
+          </a:xfrm>
+        </p:spPr>
+        <p:txBody>
+          <a:bodyPr/>
+          <a:lstStyle/>
+          <a:p>
+            <a:r>
+              <a:rPr lang="da-DK" dirty="0"/>
+              <a:t>Manual </a:t>
+            </a:r>
+            <a:r>
+              <a:rPr lang="da-DK" dirty="0" err="1"/>
+              <a:t>seperator</a:t>
+            </a:r>
+            <a:r>
+              <a:rPr lang="da-DK" dirty="0"/>
+              <a:t> og hensyn til </a:t>
+            </a:r>
+            <a:r>
+              <a:rPr lang="da-DK" dirty="0" err="1"/>
+              <a:t>quotation</a:t>
+            </a:r>
+            <a:r>
+              <a:rPr lang="da-DK" dirty="0"/>
+              <a:t>:</a:t>
+            </a:r>
+          </a:p>
+          <a:p>
+            <a:endParaRPr lang="da-DK" dirty="0"/>
+          </a:p>
+          <a:p>
+            <a:pPr marL="0" indent="0">
+              <a:buNone/>
+            </a:pPr>
+            <a:endParaRPr lang="da-DK" dirty="0"/>
+          </a:p>
+        </p:txBody>
+      </p:sp>
+      <p:pic>
+        <p:nvPicPr>
+          <p:cNvPr id="7" name="Billede 6">
+            <a:extLst>
+              <a:ext uri="{FF2B5EF4-FFF2-40B4-BE49-F238E27FC236}">
+                <a16:creationId xmlns:a16="http://schemas.microsoft.com/office/drawing/2014/main" id="{D1A8F63A-4074-6901-6774-F0F3A5DB9967}"/>
+              </a:ext>
+            </a:extLst>
+          </p:cNvPr>
+          <p:cNvPicPr>
+            <a:picLocks noChangeAspect="1"/>
+          </p:cNvPicPr>
+          <p:nvPr/>
+        </p:nvPicPr>
+        <p:blipFill>
+          <a:blip r:embed="rId2"/>
+          <a:stretch>
+            <a:fillRect/>
+          </a:stretch>
+        </p:blipFill>
+        <p:spPr>
+          <a:xfrm>
+            <a:off x="838200" y="2223140"/>
+            <a:ext cx="4857932" cy="2324088"/>
+          </a:xfrm>
+          <a:prstGeom prst="rect">
+            <a:avLst/>
+          </a:prstGeom>
+        </p:spPr>
+      </p:pic>
+      <p:pic>
+        <p:nvPicPr>
+          <p:cNvPr id="5" name="Billede 4">
+            <a:extLst>
+              <a:ext uri="{FF2B5EF4-FFF2-40B4-BE49-F238E27FC236}">
+                <a16:creationId xmlns:a16="http://schemas.microsoft.com/office/drawing/2014/main" id="{09420D67-6446-4DEA-B526-6C0CBA80E608}"/>
+              </a:ext>
+            </a:extLst>
+          </p:cNvPr>
+          <p:cNvPicPr>
+            <a:picLocks noChangeAspect="1"/>
+          </p:cNvPicPr>
+          <p:nvPr/>
+        </p:nvPicPr>
+        <p:blipFill>
+          <a:blip r:embed="rId3"/>
+          <a:stretch>
+            <a:fillRect/>
+          </a:stretch>
+        </p:blipFill>
+        <p:spPr>
+          <a:xfrm>
+            <a:off x="5659437" y="1984248"/>
+            <a:ext cx="6532563" cy="4091570"/>
+          </a:xfrm>
+          <a:prstGeom prst="rect">
+            <a:avLst/>
+          </a:prstGeom>
+        </p:spPr>
+      </p:pic>
     </p:spTree>
     <p:extLst>
       <p:ext uri="{BB962C8B-B14F-4D97-AF65-F5344CB8AC3E}">
-        <p14:creationId xmlns:p14="http://schemas.microsoft.com/office/powerpoint/2010/main" val="1447179391"/>
+        <p14:creationId xmlns:p14="http://schemas.microsoft.com/office/powerpoint/2010/main" val="4026168025"/>
+      </p:ext>
+    </p:extLst>
+  </p:cSld>
+  <p:clrMapOvr>
+    <a:masterClrMapping/>
+  </p:clrMapOvr>
+</p:sld>
+</file>
+
+<file path=ppt/slides/slide11.xml><?xml version="1.0" encoding="utf-8"?>
+<p:sld xmlns:a="http://schemas.openxmlformats.org/drawingml/2006/main" xmlns:r="http://schemas.openxmlformats.org/officeDocument/2006/relationships" xmlns:p="http://schemas.openxmlformats.org/presentationml/2006/main">
+  <p:cSld>
+    <p:spTree>
+      <p:nvGrpSpPr>
+        <p:cNvPr id="1" name=""/>
+        <p:cNvGrpSpPr/>
+        <p:nvPr/>
+      </p:nvGrpSpPr>
+      <p:grpSpPr>
+        <a:xfrm>
+          <a:off x="0" y="0"/>
+          <a:ext cx="0" cy="0"/>
+          <a:chOff x="0" y="0"/>
+          <a:chExt cx="0" cy="0"/>
+        </a:xfrm>
+      </p:grpSpPr>
+      <p:sp>
+        <p:nvSpPr>
+          <p:cNvPr id="2" name="Titel 1">
+            <a:extLst>
+              <a:ext uri="{FF2B5EF4-FFF2-40B4-BE49-F238E27FC236}">
+                <a16:creationId xmlns:a16="http://schemas.microsoft.com/office/drawing/2014/main" id="{6C535205-40D6-9ABF-9C84-3DAB9CA2C5C2}"/>
+              </a:ext>
+            </a:extLst>
+          </p:cNvPr>
+          <p:cNvSpPr>
+            <a:spLocks noGrp="1"/>
+          </p:cNvSpPr>
+          <p:nvPr>
+            <p:ph type="title"/>
+          </p:nvPr>
+        </p:nvSpPr>
+        <p:spPr/>
+        <p:txBody>
+          <a:bodyPr/>
+          <a:lstStyle/>
+          <a:p>
+            <a:r>
+              <a:rPr lang="da-DK" dirty="0"/>
+              <a:t>Demo af parser(ekstra)</a:t>
+            </a:r>
+          </a:p>
+        </p:txBody>
+      </p:sp>
+      <p:sp>
+        <p:nvSpPr>
+          <p:cNvPr id="5" name="Pladsholder til indhold 4">
+            <a:extLst>
+              <a:ext uri="{FF2B5EF4-FFF2-40B4-BE49-F238E27FC236}">
+                <a16:creationId xmlns:a16="http://schemas.microsoft.com/office/drawing/2014/main" id="{10452743-7C97-DC3B-2DD6-ED0CEAAF1CAD}"/>
+              </a:ext>
+            </a:extLst>
+          </p:cNvPr>
+          <p:cNvSpPr>
+            <a:spLocks noGrp="1"/>
+          </p:cNvSpPr>
+          <p:nvPr>
+            <p:ph idx="1"/>
+          </p:nvPr>
+        </p:nvSpPr>
+        <p:spPr>
+          <a:prstGeom prst="rect">
+            <a:avLst/>
+          </a:prstGeom>
+        </p:spPr>
+        <p:style>
+          <a:lnRef idx="2">
+            <a:schemeClr val="accent1">
+              <a:shade val="15000"/>
+            </a:schemeClr>
+          </a:lnRef>
+          <a:fillRef idx="1">
+            <a:schemeClr val="accent1"/>
+          </a:fillRef>
+          <a:effectRef idx="0">
+            <a:schemeClr val="accent1"/>
+          </a:effectRef>
+          <a:fontRef idx="minor">
+            <a:schemeClr val="lt1"/>
+          </a:fontRef>
+        </p:style>
+        <p:txBody>
+          <a:bodyPr rtlCol="0" anchor="ctr"/>
+          <a:lstStyle/>
+          <a:p>
+            <a:pPr algn="ctr"/>
+            <a:r>
+              <a:rPr lang="da-DK" dirty="0" err="1"/>
+              <a:t>Parser_no_head</a:t>
+            </a:r>
+            <a:r>
+              <a:rPr lang="da-DK" dirty="0"/>
+              <a:t>=Parser(header=False)</a:t>
+            </a:r>
+          </a:p>
+          <a:p>
+            <a:pPr algn="ctr"/>
+            <a:r>
+              <a:rPr lang="da-DK" dirty="0" err="1"/>
+              <a:t>Parser_sep_dif</a:t>
+            </a:r>
+            <a:r>
+              <a:rPr lang="da-DK" dirty="0"/>
+              <a:t>=(</a:t>
+            </a:r>
+            <a:r>
+              <a:rPr lang="da-DK" dirty="0" err="1"/>
+              <a:t>seperator</a:t>
+            </a:r>
+            <a:r>
+              <a:rPr lang="da-DK" dirty="0"/>
+              <a:t>=”/s ”)</a:t>
+            </a:r>
+          </a:p>
+          <a:p>
+            <a:pPr algn="ctr"/>
+            <a:endParaRPr lang="da-DK" dirty="0"/>
+          </a:p>
+          <a:p>
+            <a:pPr algn="ctr"/>
+            <a:r>
+              <a:rPr lang="da-DK" dirty="0" err="1"/>
+              <a:t>Parser_no_head.parse</a:t>
+            </a:r>
+            <a:r>
+              <a:rPr lang="da-DK" dirty="0"/>
+              <a:t>(”Hans, </a:t>
+            </a:r>
+            <a:r>
+              <a:rPr lang="da-DK" dirty="0" err="1"/>
+              <a:t>Obiby</a:t>
+            </a:r>
+            <a:r>
+              <a:rPr lang="da-DK" dirty="0"/>
+              <a:t>”)</a:t>
+            </a:r>
+          </a:p>
+          <a:p>
+            <a:pPr algn="ctr"/>
+            <a:r>
+              <a:rPr lang="da-DK" dirty="0" err="1"/>
+              <a:t>Parser_sep_dif.parse</a:t>
+            </a:r>
+            <a:r>
+              <a:rPr lang="da-DK" dirty="0"/>
+              <a:t>(”Hans/</a:t>
+            </a:r>
+            <a:r>
+              <a:rPr lang="da-DK" dirty="0" err="1"/>
+              <a:t>sObiby</a:t>
+            </a:r>
+            <a:r>
+              <a:rPr lang="da-DK" dirty="0"/>
+              <a:t> ”)</a:t>
+            </a:r>
+          </a:p>
+        </p:txBody>
+      </p:sp>
+    </p:spTree>
+    <p:extLst>
+      <p:ext uri="{BB962C8B-B14F-4D97-AF65-F5344CB8AC3E}">
+        <p14:creationId xmlns:p14="http://schemas.microsoft.com/office/powerpoint/2010/main" val="2606010687"/>
       </p:ext>
     </p:extLst>
   </p:cSld>
@@ -4732,7 +4988,7 @@
         </p:nvSpPr>
         <p:spPr>
           <a:xfrm>
-            <a:off x="838200" y="1505585"/>
+            <a:off x="765048" y="1333073"/>
             <a:ext cx="10515600" cy="4351338"/>
           </a:xfrm>
         </p:spPr>
@@ -4742,7 +4998,15 @@
           <a:p>
             <a:r>
               <a:rPr lang="da-DK" dirty="0"/>
-              <a:t>Parser som en class:</a:t>
+              <a:t>Parser som en class: Objekt er parseren med </a:t>
+            </a:r>
+            <a:r>
+              <a:rPr lang="da-DK" dirty="0" err="1"/>
+              <a:t>method</a:t>
+            </a:r>
+            <a:r>
+              <a:rPr lang="da-DK" dirty="0"/>
+              <a:t> parse().</a:t>
             </a:r>
           </a:p>
           <a:p>
@@ -4787,20 +5051,59 @@
         </p:blipFill>
         <p:spPr>
           <a:xfrm>
-            <a:off x="938784" y="1989555"/>
-            <a:ext cx="8158027" cy="1516677"/>
+            <a:off x="838200" y="1852140"/>
+            <a:ext cx="6623304" cy="1231353"/>
           </a:xfrm>
           <a:prstGeom prst="rect">
             <a:avLst/>
           </a:prstGeom>
         </p:spPr>
       </p:pic>
+      <p:sp>
+        <p:nvSpPr>
+          <p:cNvPr id="11" name="Tekstfelt 10">
+            <a:extLst>
+              <a:ext uri="{FF2B5EF4-FFF2-40B4-BE49-F238E27FC236}">
+                <a16:creationId xmlns:a16="http://schemas.microsoft.com/office/drawing/2014/main" id="{71E7D8F1-3C8A-04B9-0D32-F31ACA9861B1}"/>
+              </a:ext>
+            </a:extLst>
+          </p:cNvPr>
+          <p:cNvSpPr txBox="1"/>
+          <p:nvPr/>
+        </p:nvSpPr>
+        <p:spPr>
+          <a:xfrm>
+            <a:off x="691896" y="3519468"/>
+            <a:ext cx="3997322" cy="369332"/>
+          </a:xfrm>
+          <a:prstGeom prst="rect">
+            <a:avLst/>
+          </a:prstGeom>
+          <a:noFill/>
+        </p:spPr>
+        <p:txBody>
+          <a:bodyPr wrap="square" rtlCol="0">
+            <a:spAutoFit/>
+          </a:bodyPr>
+          <a:lstStyle/>
+          <a:p>
+            <a:pPr marL="285750" indent="-285750">
+              <a:buFont typeface="Arial" panose="020B0604020202020204" pitchFamily="34" charset="0"/>
+              <a:buChar char="•"/>
+            </a:pPr>
+            <a:r>
+              <a:rPr lang="da-DK" dirty="0"/>
+              <a:t>Forskellige parsere mulige:</a:t>
+            </a:r>
+          </a:p>
+        </p:txBody>
+      </p:sp>
       <p:pic>
         <p:nvPicPr>
-          <p:cNvPr id="9" name="Billede 8">
-            <a:extLst>
-              <a:ext uri="{FF2B5EF4-FFF2-40B4-BE49-F238E27FC236}">
-                <a16:creationId xmlns:a16="http://schemas.microsoft.com/office/drawing/2014/main" id="{A6BABC31-8B66-1865-85ED-6E5E15142E7B}"/>
+          <p:cNvPr id="6" name="Billede 5">
+            <a:extLst>
+              <a:ext uri="{FF2B5EF4-FFF2-40B4-BE49-F238E27FC236}">
+                <a16:creationId xmlns:a16="http://schemas.microsoft.com/office/drawing/2014/main" id="{1E4CD6C9-7333-8F04-811F-D19D86F09D88}"/>
               </a:ext>
             </a:extLst>
           </p:cNvPr>
@@ -4817,163 +5120,14 @@
         </p:blipFill>
         <p:spPr>
           <a:xfrm>
-            <a:off x="1015079" y="3681254"/>
-            <a:ext cx="5443538" cy="2980769"/>
+            <a:off x="4383411" y="2286814"/>
+            <a:ext cx="7116693" cy="4572000"/>
           </a:xfrm>
           <a:prstGeom prst="rect">
             <a:avLst/>
           </a:prstGeom>
         </p:spPr>
       </p:pic>
-      <p:sp>
-        <p:nvSpPr>
-          <p:cNvPr id="10" name="Rektangel 9">
-            <a:extLst>
-              <a:ext uri="{FF2B5EF4-FFF2-40B4-BE49-F238E27FC236}">
-                <a16:creationId xmlns:a16="http://schemas.microsoft.com/office/drawing/2014/main" id="{6D42A402-F0E0-BB0E-1A3C-27256633E166}"/>
-              </a:ext>
-            </a:extLst>
-          </p:cNvPr>
-          <p:cNvSpPr/>
-          <p:nvPr/>
-        </p:nvSpPr>
-        <p:spPr>
-          <a:xfrm>
-            <a:off x="6994428" y="4311332"/>
-            <a:ext cx="4359372" cy="1689791"/>
-          </a:xfrm>
-          <a:prstGeom prst="rect">
-            <a:avLst/>
-          </a:prstGeom>
-        </p:spPr>
-        <p:style>
-          <a:lnRef idx="2">
-            <a:schemeClr val="accent1">
-              <a:shade val="15000"/>
-            </a:schemeClr>
-          </a:lnRef>
-          <a:fillRef idx="1">
-            <a:schemeClr val="accent1"/>
-          </a:fillRef>
-          <a:effectRef idx="0">
-            <a:schemeClr val="accent1"/>
-          </a:effectRef>
-          <a:fontRef idx="minor">
-            <a:schemeClr val="lt1"/>
-          </a:fontRef>
-        </p:style>
-        <p:txBody>
-          <a:bodyPr rtlCol="0" anchor="ctr"/>
-          <a:lstStyle/>
-          <a:p>
-            <a:pPr algn="ctr"/>
-            <a:r>
-              <a:rPr lang="da-DK" dirty="0" err="1"/>
-              <a:t>Parser_no_head</a:t>
-            </a:r>
-            <a:r>
-              <a:rPr lang="da-DK" dirty="0"/>
-              <a:t>=Parser(header=False)</a:t>
-            </a:r>
-          </a:p>
-          <a:p>
-            <a:pPr algn="ctr"/>
-            <a:r>
-              <a:rPr lang="da-DK" dirty="0" err="1"/>
-              <a:t>Parser_sep_dif</a:t>
-            </a:r>
-            <a:r>
-              <a:rPr lang="da-DK" dirty="0"/>
-              <a:t>=(</a:t>
-            </a:r>
-            <a:r>
-              <a:rPr lang="da-DK" dirty="0" err="1"/>
-              <a:t>seperator</a:t>
-            </a:r>
-            <a:r>
-              <a:rPr lang="da-DK" dirty="0"/>
-              <a:t>=”/s ”)</a:t>
-            </a:r>
-          </a:p>
-          <a:p>
-            <a:pPr algn="ctr"/>
-            <a:endParaRPr lang="da-DK" dirty="0"/>
-          </a:p>
-          <a:p>
-            <a:pPr algn="ctr"/>
-            <a:r>
-              <a:rPr lang="da-DK" dirty="0" err="1"/>
-              <a:t>Parser_no_head.parse</a:t>
-            </a:r>
-            <a:r>
-              <a:rPr lang="da-DK" dirty="0"/>
-              <a:t>(”Hans, </a:t>
-            </a:r>
-            <a:r>
-              <a:rPr lang="da-DK" dirty="0" err="1"/>
-              <a:t>Obiby</a:t>
-            </a:r>
-            <a:r>
-              <a:rPr lang="da-DK" dirty="0"/>
-              <a:t>”)</a:t>
-            </a:r>
-          </a:p>
-          <a:p>
-            <a:pPr algn="ctr"/>
-            <a:r>
-              <a:rPr lang="da-DK" dirty="0" err="1"/>
-              <a:t>Parser_sep_dif.parse</a:t>
-            </a:r>
-            <a:r>
-              <a:rPr lang="da-DK" dirty="0"/>
-              <a:t>(”Hans/</a:t>
-            </a:r>
-            <a:r>
-              <a:rPr lang="da-DK" dirty="0" err="1"/>
-              <a:t>sObiby</a:t>
-            </a:r>
-            <a:r>
-              <a:rPr lang="da-DK" dirty="0"/>
-              <a:t> ”)</a:t>
-            </a:r>
-          </a:p>
-        </p:txBody>
-      </p:sp>
-      <p:sp>
-        <p:nvSpPr>
-          <p:cNvPr id="11" name="Tekstfelt 10">
-            <a:extLst>
-              <a:ext uri="{FF2B5EF4-FFF2-40B4-BE49-F238E27FC236}">
-                <a16:creationId xmlns:a16="http://schemas.microsoft.com/office/drawing/2014/main" id="{71E7D8F1-3C8A-04B9-0D32-F31ACA9861B1}"/>
-              </a:ext>
-            </a:extLst>
-          </p:cNvPr>
-          <p:cNvSpPr txBox="1"/>
-          <p:nvPr/>
-        </p:nvSpPr>
-        <p:spPr>
-          <a:xfrm>
-            <a:off x="6907547" y="3724116"/>
-            <a:ext cx="3997322" cy="369332"/>
-          </a:xfrm>
-          <a:prstGeom prst="rect">
-            <a:avLst/>
-          </a:prstGeom>
-          <a:noFill/>
-        </p:spPr>
-        <p:txBody>
-          <a:bodyPr wrap="square" rtlCol="0">
-            <a:spAutoFit/>
-          </a:bodyPr>
-          <a:lstStyle/>
-          <a:p>
-            <a:r>
-              <a:rPr lang="da-DK" dirty="0"/>
-              <a:t>Forskellige parsere mulige:</a:t>
-            </a:r>
-          </a:p>
-        </p:txBody>
-      </p:sp>
     </p:spTree>
     <p:extLst>
       <p:ext uri="{BB962C8B-B14F-4D97-AF65-F5344CB8AC3E}">
@@ -5009,7 +5163,7 @@
           <p:cNvPr id="2" name="Titel 1">
             <a:extLst>
               <a:ext uri="{FF2B5EF4-FFF2-40B4-BE49-F238E27FC236}">
-                <a16:creationId xmlns:a16="http://schemas.microsoft.com/office/drawing/2014/main" id="{2BA640CE-B359-C502-D5FE-2C086BD26106}"/>
+                <a16:creationId xmlns:a16="http://schemas.microsoft.com/office/drawing/2014/main" id="{8475D01E-D5F9-FFB2-3B97-7FE242157DBB}"/>
               </a:ext>
             </a:extLst>
           </p:cNvPr>
@@ -5027,70 +5181,52 @@
           <a:p>
             <a:r>
               <a:rPr lang="da-DK" dirty="0"/>
-              <a:t>Særlige funktioner</a:t>
-            </a:r>
-          </a:p>
-        </p:txBody>
-      </p:sp>
-      <p:sp>
-        <p:nvSpPr>
-          <p:cNvPr id="3" name="Pladsholder til indhold 2">
-            <a:extLst>
-              <a:ext uri="{FF2B5EF4-FFF2-40B4-BE49-F238E27FC236}">
-                <a16:creationId xmlns:a16="http://schemas.microsoft.com/office/drawing/2014/main" id="{A4C80449-42F7-02F3-176C-58786BAD9DCE}"/>
-              </a:ext>
-            </a:extLst>
-          </p:cNvPr>
-          <p:cNvSpPr>
-            <a:spLocks noGrp="1"/>
-          </p:cNvSpPr>
-          <p:nvPr>
-            <p:ph idx="1"/>
-          </p:nvPr>
-        </p:nvSpPr>
-        <p:spPr/>
-        <p:txBody>
-          <a:bodyPr/>
-          <a:lstStyle/>
-          <a:p>
-            <a:r>
-              <a:rPr lang="da-DK" dirty="0"/>
-              <a:t>Manual </a:t>
-            </a:r>
-            <a:r>
-              <a:rPr lang="da-DK" dirty="0" err="1"/>
-              <a:t>seperator</a:t>
-            </a:r>
-            <a:r>
-              <a:rPr lang="da-DK" dirty="0"/>
-              <a:t> og hensyn til </a:t>
-            </a:r>
-            <a:r>
-              <a:rPr lang="da-DK" dirty="0" err="1"/>
-              <a:t>quotation</a:t>
-            </a:r>
-            <a:r>
-              <a:rPr lang="da-DK" dirty="0"/>
-              <a:t>:</a:t>
-            </a:r>
-          </a:p>
-          <a:p>
-            <a:endParaRPr lang="da-DK" dirty="0"/>
-          </a:p>
-          <a:p>
-            <a:pPr marL="0" indent="0">
-              <a:buNone/>
-            </a:pPr>
-            <a:endParaRPr lang="da-DK" dirty="0"/>
+              <a:t>UML diagram</a:t>
+            </a:r>
+          </a:p>
+        </p:txBody>
+      </p:sp>
+      <p:sp>
+        <p:nvSpPr>
+          <p:cNvPr id="6" name="Tekstfelt 5">
+            <a:extLst>
+              <a:ext uri="{FF2B5EF4-FFF2-40B4-BE49-F238E27FC236}">
+                <a16:creationId xmlns:a16="http://schemas.microsoft.com/office/drawing/2014/main" id="{E1842303-7971-EAD8-2F0F-2B88C79F1CAD}"/>
+              </a:ext>
+            </a:extLst>
+          </p:cNvPr>
+          <p:cNvSpPr txBox="1"/>
+          <p:nvPr/>
+        </p:nvSpPr>
+        <p:spPr>
+          <a:xfrm>
+            <a:off x="838200" y="1321356"/>
+            <a:ext cx="3401568" cy="369332"/>
+          </a:xfrm>
+          <a:prstGeom prst="rect">
+            <a:avLst/>
+          </a:prstGeom>
+          <a:noFill/>
+        </p:spPr>
+        <p:txBody>
+          <a:bodyPr wrap="square" rtlCol="0">
+            <a:spAutoFit/>
+          </a:bodyPr>
+          <a:lstStyle/>
+          <a:p>
+            <a:r>
+              <a:rPr lang="da-DK" dirty="0"/>
+              <a:t>Enkel med header og ikke JSON:</a:t>
+            </a:r>
           </a:p>
         </p:txBody>
       </p:sp>
       <p:pic>
         <p:nvPicPr>
-          <p:cNvPr id="7" name="Billede 6">
-            <a:extLst>
-              <a:ext uri="{FF2B5EF4-FFF2-40B4-BE49-F238E27FC236}">
-                <a16:creationId xmlns:a16="http://schemas.microsoft.com/office/drawing/2014/main" id="{D1A8F63A-4074-6901-6774-F0F3A5DB9967}"/>
+          <p:cNvPr id="9" name="Billede 8">
+            <a:extLst>
+              <a:ext uri="{FF2B5EF4-FFF2-40B4-BE49-F238E27FC236}">
+                <a16:creationId xmlns:a16="http://schemas.microsoft.com/office/drawing/2014/main" id="{63A12A76-3EAE-B98C-25D1-8E63C1CAE24B}"/>
               </a:ext>
             </a:extLst>
           </p:cNvPr>
@@ -5107,8 +5243,8 @@
         </p:blipFill>
         <p:spPr>
           <a:xfrm>
-            <a:off x="838200" y="2329059"/>
-            <a:ext cx="5515745" cy="2638793"/>
+            <a:off x="4532614" y="203909"/>
+            <a:ext cx="7192804" cy="6126255"/>
           </a:xfrm>
           <a:prstGeom prst="rect">
             <a:avLst/>
@@ -5118,7 +5254,7 @@
     </p:spTree>
     <p:extLst>
       <p:ext uri="{BB962C8B-B14F-4D97-AF65-F5344CB8AC3E}">
-        <p14:creationId xmlns:p14="http://schemas.microsoft.com/office/powerpoint/2010/main" val="4026168025"/>
+        <p14:creationId xmlns:p14="http://schemas.microsoft.com/office/powerpoint/2010/main" val="1034216412"/>
       </p:ext>
     </p:extLst>
   </p:cSld>
@@ -5150,7 +5286,7 @@
           <p:cNvPr id="2" name="Titel 1">
             <a:extLst>
               <a:ext uri="{FF2B5EF4-FFF2-40B4-BE49-F238E27FC236}">
-                <a16:creationId xmlns:a16="http://schemas.microsoft.com/office/drawing/2014/main" id="{8475D01E-D5F9-FFB2-3B97-7FE242157DBB}"/>
+                <a16:creationId xmlns:a16="http://schemas.microsoft.com/office/drawing/2014/main" id="{D75D472D-CBB3-D4D2-6744-7B0DE3F10EFE}"/>
               </a:ext>
             </a:extLst>
           </p:cNvPr>
@@ -5168,80 +5304,279 @@
           <a:p>
             <a:r>
               <a:rPr lang="da-DK" dirty="0"/>
-              <a:t>UML diagram</a:t>
-            </a:r>
-          </a:p>
-        </p:txBody>
-      </p:sp>
-      <p:sp>
-        <p:nvSpPr>
-          <p:cNvPr id="6" name="Tekstfelt 5">
-            <a:extLst>
-              <a:ext uri="{FF2B5EF4-FFF2-40B4-BE49-F238E27FC236}">
-                <a16:creationId xmlns:a16="http://schemas.microsoft.com/office/drawing/2014/main" id="{E1842303-7971-EAD8-2F0F-2B88C79F1CAD}"/>
-              </a:ext>
-            </a:extLst>
-          </p:cNvPr>
-          <p:cNvSpPr txBox="1"/>
-          <p:nvPr/>
+              <a:t>Demo af parser</a:t>
+            </a:r>
+          </a:p>
+        </p:txBody>
+      </p:sp>
+      <p:sp>
+        <p:nvSpPr>
+          <p:cNvPr id="3" name="Pladsholder til indhold 2">
+            <a:extLst>
+              <a:ext uri="{FF2B5EF4-FFF2-40B4-BE49-F238E27FC236}">
+                <a16:creationId xmlns:a16="http://schemas.microsoft.com/office/drawing/2014/main" id="{E93DFFF5-61F5-3E8B-2721-726EFA21C44D}"/>
+              </a:ext>
+            </a:extLst>
+          </p:cNvPr>
+          <p:cNvSpPr>
+            <a:spLocks noGrp="1"/>
+          </p:cNvSpPr>
+          <p:nvPr>
+            <p:ph idx="1"/>
+          </p:nvPr>
         </p:nvSpPr>
         <p:spPr>
           <a:xfrm>
-            <a:off x="838200" y="1321356"/>
-            <a:ext cx="3401568" cy="369332"/>
+            <a:off x="838200" y="1514728"/>
+            <a:ext cx="10710672" cy="4831207"/>
           </a:xfrm>
-          <a:prstGeom prst="rect">
-            <a:avLst/>
-          </a:prstGeom>
-          <a:noFill/>
         </p:spPr>
         <p:txBody>
-          <a:bodyPr wrap="square" rtlCol="0">
-            <a:spAutoFit/>
+          <a:bodyPr>
+            <a:normAutofit fontScale="92500"/>
           </a:bodyPr>
           <a:lstStyle/>
           <a:p>
             <a:r>
-              <a:rPr lang="da-DK" dirty="0"/>
-              <a:t>Enkel med header og ikke JSON:</a:t>
-            </a:r>
-          </a:p>
-        </p:txBody>
-      </p:sp>
-      <p:pic>
-        <p:nvPicPr>
-          <p:cNvPr id="9" name="Billede 8">
-            <a:extLst>
-              <a:ext uri="{FF2B5EF4-FFF2-40B4-BE49-F238E27FC236}">
-                <a16:creationId xmlns:a16="http://schemas.microsoft.com/office/drawing/2014/main" id="{63A12A76-3EAE-B98C-25D1-8E63C1CAE24B}"/>
-              </a:ext>
-            </a:extLst>
-          </p:cNvPr>
-          <p:cNvPicPr>
-            <a:picLocks noChangeAspect="1"/>
-          </p:cNvPicPr>
-          <p:nvPr/>
-        </p:nvPicPr>
-        <p:blipFill>
-          <a:blip r:embed="rId2"/>
-          <a:stretch>
-            <a:fillRect/>
-          </a:stretch>
-        </p:blipFill>
-        <p:spPr>
-          <a:xfrm>
-            <a:off x="4648676" y="573556"/>
-            <a:ext cx="6705124" cy="5710888"/>
-          </a:xfrm>
-          <a:prstGeom prst="rect">
-            <a:avLst/>
-          </a:prstGeom>
-        </p:spPr>
-      </p:pic>
+              <a:rPr lang="da-DK" dirty="0" err="1"/>
+              <a:t>csv</a:t>
+            </a:r>
+            <a:r>
+              <a:rPr lang="da-DK" dirty="0"/>
+              <a:t>="</a:t>
+            </a:r>
+            <a:r>
+              <a:rPr lang="da-DK" dirty="0" err="1"/>
+              <a:t>name</a:t>
+            </a:r>
+            <a:r>
+              <a:rPr lang="da-DK" dirty="0" err="1">
+                <a:solidFill>
+                  <a:srgbClr val="FF0000"/>
+                </a:solidFill>
+              </a:rPr>
+              <a:t>,</a:t>
+            </a:r>
+            <a:r>
+              <a:rPr lang="da-DK" dirty="0" err="1"/>
+              <a:t>email</a:t>
+            </a:r>
+            <a:r>
+              <a:rPr lang="da-DK" dirty="0">
+                <a:solidFill>
+                  <a:srgbClr val="FF0000"/>
+                </a:solidFill>
+              </a:rPr>
+              <a:t>\</a:t>
+            </a:r>
+            <a:r>
+              <a:rPr lang="da-DK" dirty="0" err="1">
+                <a:solidFill>
+                  <a:srgbClr val="FF0000"/>
+                </a:solidFill>
+              </a:rPr>
+              <a:t>n</a:t>
+            </a:r>
+            <a:r>
+              <a:rPr lang="da-DK" dirty="0" err="1"/>
+              <a:t>Marcus</a:t>
+            </a:r>
+            <a:r>
+              <a:rPr lang="da-DK" dirty="0"/>
+              <a:t> </a:t>
+            </a:r>
+            <a:r>
+              <a:rPr lang="da-DK" dirty="0" err="1"/>
+              <a:t>Chen</a:t>
+            </a:r>
+            <a:r>
+              <a:rPr lang="da-DK" dirty="0" err="1">
+                <a:solidFill>
+                  <a:srgbClr val="FF0000"/>
+                </a:solidFill>
+              </a:rPr>
+              <a:t>,</a:t>
+            </a:r>
+            <a:r>
+              <a:rPr lang="da-DK" dirty="0" err="1"/>
+              <a:t>marcus.chen@example.com</a:t>
+            </a:r>
+            <a:r>
+              <a:rPr lang="da-DK" dirty="0">
+                <a:solidFill>
+                  <a:srgbClr val="FF0000"/>
+                </a:solidFill>
+              </a:rPr>
+              <a:t>\</a:t>
+            </a:r>
+            <a:r>
+              <a:rPr lang="da-DK" dirty="0" err="1">
+                <a:solidFill>
+                  <a:srgbClr val="FF0000"/>
+                </a:solidFill>
+              </a:rPr>
+              <a:t>n</a:t>
+            </a:r>
+            <a:r>
+              <a:rPr lang="da-DK" dirty="0" err="1"/>
+              <a:t>Priya</a:t>
+            </a:r>
+            <a:r>
+              <a:rPr lang="da-DK" dirty="0"/>
+              <a:t> </a:t>
+            </a:r>
+            <a:r>
+              <a:rPr lang="da-DK" dirty="0" err="1"/>
+              <a:t>Sharma</a:t>
+            </a:r>
+            <a:r>
+              <a:rPr lang="da-DK" dirty="0" err="1">
+                <a:solidFill>
+                  <a:srgbClr val="FF0000"/>
+                </a:solidFill>
+              </a:rPr>
+              <a:t>,</a:t>
+            </a:r>
+            <a:r>
+              <a:rPr lang="da-DK" dirty="0" err="1"/>
+              <a:t>priya.sharma@example.com</a:t>
+            </a:r>
+            <a:r>
+              <a:rPr lang="da-DK" dirty="0"/>
+              <a:t>”</a:t>
+            </a:r>
+          </a:p>
+          <a:p>
+            <a:pPr marL="0" indent="0">
+              <a:buNone/>
+            </a:pPr>
+            <a:endParaRPr lang="da-DK" dirty="0"/>
+          </a:p>
+          <a:p>
+            <a:r>
+              <a:rPr lang="da-DK" dirty="0"/>
+              <a:t>parser=Parser()</a:t>
+            </a:r>
+          </a:p>
+          <a:p>
+            <a:pPr lvl="1"/>
+            <a:r>
+              <a:rPr lang="da-DK" dirty="0"/>
+              <a:t>Husk betyder header=</a:t>
+            </a:r>
+            <a:r>
+              <a:rPr lang="da-DK" dirty="0" err="1"/>
+              <a:t>True,seperator</a:t>
+            </a:r>
+            <a:r>
+              <a:rPr lang="da-DK" dirty="0"/>
+              <a:t>=",", </a:t>
+            </a:r>
+            <a:r>
+              <a:rPr lang="da-DK" dirty="0" err="1"/>
+              <a:t>lineseperator</a:t>
+            </a:r>
+            <a:r>
+              <a:rPr lang="da-DK" dirty="0"/>
+              <a:t>=["\n","\r"], </a:t>
+            </a:r>
+            <a:r>
+              <a:rPr lang="da-DK" dirty="0" err="1"/>
+              <a:t>Json</a:t>
+            </a:r>
+            <a:r>
+              <a:rPr lang="da-DK" dirty="0"/>
+              <a:t>=False</a:t>
+            </a:r>
+          </a:p>
+          <a:p>
+            <a:pPr marL="457200" lvl="1" indent="0">
+              <a:buNone/>
+            </a:pPr>
+            <a:endParaRPr lang="da-DK" dirty="0"/>
+          </a:p>
+          <a:p>
+            <a:r>
+              <a:rPr lang="da-DK" dirty="0"/>
+              <a:t>Print(</a:t>
+            </a:r>
+            <a:r>
+              <a:rPr lang="da-DK" dirty="0" err="1"/>
+              <a:t>parser.parse</a:t>
+            </a:r>
+            <a:r>
+              <a:rPr lang="da-DK" dirty="0"/>
+              <a:t>(CSV))</a:t>
+            </a:r>
+          </a:p>
+          <a:p>
+            <a:pPr marL="0" indent="0">
+              <a:buNone/>
+            </a:pPr>
+            <a:endParaRPr lang="da-DK" dirty="0"/>
+          </a:p>
+          <a:p>
+            <a:pPr marL="0" indent="0">
+              <a:buNone/>
+            </a:pPr>
+            <a:r>
+              <a:rPr lang="da-DK" dirty="0"/>
+              <a:t>Output:</a:t>
+            </a:r>
+          </a:p>
+          <a:p>
+            <a:pPr marL="0" indent="0">
+              <a:buNone/>
+            </a:pPr>
+            <a:r>
+              <a:rPr lang="da-DK" dirty="0"/>
+              <a:t>[{'</a:t>
+            </a:r>
+            <a:r>
+              <a:rPr lang="da-DK" dirty="0" err="1"/>
+              <a:t>name</a:t>
+            </a:r>
+            <a:r>
+              <a:rPr lang="da-DK" dirty="0"/>
+              <a:t>': 'Marcus Chen', '</a:t>
+            </a:r>
+            <a:r>
+              <a:rPr lang="da-DK" dirty="0" err="1"/>
+              <a:t>email</a:t>
+            </a:r>
+            <a:r>
+              <a:rPr lang="da-DK" dirty="0"/>
+              <a:t>': 'marcus.chen@example.com'}, {'</a:t>
+            </a:r>
+            <a:r>
+              <a:rPr lang="da-DK" dirty="0" err="1"/>
+              <a:t>name</a:t>
+            </a:r>
+            <a:r>
+              <a:rPr lang="da-DK" dirty="0"/>
+              <a:t>': 'Priya Sharma', '</a:t>
+            </a:r>
+            <a:r>
+              <a:rPr lang="da-DK" dirty="0" err="1"/>
+              <a:t>email</a:t>
+            </a:r>
+            <a:r>
+              <a:rPr lang="da-DK" dirty="0"/>
+              <a:t>': 'priya.sharma@example.com'}]</a:t>
+            </a:r>
+          </a:p>
+          <a:p>
+            <a:endParaRPr lang="da-DK" dirty="0"/>
+          </a:p>
+          <a:p>
+            <a:endParaRPr lang="da-DK" dirty="0"/>
+          </a:p>
+        </p:txBody>
+      </p:sp>
     </p:spTree>
     <p:extLst>
       <p:ext uri="{BB962C8B-B14F-4D97-AF65-F5344CB8AC3E}">
-        <p14:creationId xmlns:p14="http://schemas.microsoft.com/office/powerpoint/2010/main" val="1034216412"/>
+        <p14:creationId xmlns:p14="http://schemas.microsoft.com/office/powerpoint/2010/main" val="858502015"/>
       </p:ext>
     </p:extLst>
   </p:cSld>
@@ -5273,7 +5608,7 @@
           <p:cNvPr id="2" name="Titel 1">
             <a:extLst>
               <a:ext uri="{FF2B5EF4-FFF2-40B4-BE49-F238E27FC236}">
-                <a16:creationId xmlns:a16="http://schemas.microsoft.com/office/drawing/2014/main" id="{D75D472D-CBB3-D4D2-6744-7B0DE3F10EFE}"/>
+                <a16:creationId xmlns:a16="http://schemas.microsoft.com/office/drawing/2014/main" id="{DCA28694-89F1-88F1-5355-980347DBFAA4}"/>
               </a:ext>
             </a:extLst>
           </p:cNvPr>
@@ -5291,7 +5626,7 @@
           <a:p>
             <a:r>
               <a:rPr lang="da-DK" dirty="0"/>
-              <a:t>Demo af parser</a:t>
+              <a:t>Hvis jeg havde mere tid</a:t>
             </a:r>
           </a:p>
         </p:txBody>
@@ -5301,7 +5636,7 @@
           <p:cNvPr id="3" name="Pladsholder til indhold 2">
             <a:extLst>
               <a:ext uri="{FF2B5EF4-FFF2-40B4-BE49-F238E27FC236}">
-                <a16:creationId xmlns:a16="http://schemas.microsoft.com/office/drawing/2014/main" id="{E93DFFF5-61F5-3E8B-2721-726EFA21C44D}"/>
+                <a16:creationId xmlns:a16="http://schemas.microsoft.com/office/drawing/2014/main" id="{F1220C65-72A9-26FD-CFBC-EE52A711C2AD}"/>
               </a:ext>
             </a:extLst>
           </p:cNvPr>
@@ -5312,258 +5647,34 @@
             <p:ph idx="1"/>
           </p:nvPr>
         </p:nvSpPr>
-        <p:spPr>
-          <a:xfrm>
-            <a:off x="838200" y="1514728"/>
-            <a:ext cx="10710672" cy="4831207"/>
-          </a:xfrm>
-        </p:spPr>
-        <p:txBody>
-          <a:bodyPr>
-            <a:normAutofit fontScale="92500"/>
-          </a:bodyPr>
-          <a:lstStyle/>
-          <a:p>
-            <a:r>
-              <a:rPr lang="da-DK" dirty="0" err="1"/>
-              <a:t>csv</a:t>
-            </a:r>
-            <a:r>
-              <a:rPr lang="da-DK" dirty="0"/>
-              <a:t>="</a:t>
-            </a:r>
-            <a:r>
-              <a:rPr lang="da-DK" dirty="0" err="1"/>
-              <a:t>name</a:t>
-            </a:r>
-            <a:r>
-              <a:rPr lang="da-DK" dirty="0" err="1">
-                <a:solidFill>
-                  <a:srgbClr val="FF0000"/>
-                </a:solidFill>
-              </a:rPr>
-              <a:t>,</a:t>
-            </a:r>
-            <a:r>
-              <a:rPr lang="da-DK" dirty="0" err="1"/>
-              <a:t>email</a:t>
-            </a:r>
-            <a:r>
-              <a:rPr lang="da-DK" dirty="0">
-                <a:solidFill>
-                  <a:srgbClr val="FF0000"/>
-                </a:solidFill>
-              </a:rPr>
-              <a:t>\</a:t>
-            </a:r>
-            <a:r>
-              <a:rPr lang="da-DK" dirty="0" err="1">
-                <a:solidFill>
-                  <a:srgbClr val="FF0000"/>
-                </a:solidFill>
-              </a:rPr>
-              <a:t>n</a:t>
-            </a:r>
-            <a:r>
-              <a:rPr lang="da-DK" dirty="0" err="1"/>
-              <a:t>Marcus</a:t>
-            </a:r>
-            <a:r>
-              <a:rPr lang="da-DK" dirty="0"/>
-              <a:t> </a:t>
-            </a:r>
-            <a:r>
-              <a:rPr lang="da-DK" dirty="0" err="1"/>
-              <a:t>Chen</a:t>
-            </a:r>
-            <a:r>
-              <a:rPr lang="da-DK" dirty="0" err="1">
-                <a:solidFill>
-                  <a:srgbClr val="FF0000"/>
-                </a:solidFill>
-              </a:rPr>
-              <a:t>,</a:t>
-            </a:r>
-            <a:r>
-              <a:rPr lang="da-DK" dirty="0" err="1"/>
-              <a:t>marcus.chen@example.com</a:t>
-            </a:r>
-            <a:r>
-              <a:rPr lang="da-DK" dirty="0">
-                <a:solidFill>
-                  <a:srgbClr val="FF0000"/>
-                </a:solidFill>
-              </a:rPr>
-              <a:t>\</a:t>
-            </a:r>
-            <a:r>
-              <a:rPr lang="da-DK" dirty="0" err="1">
-                <a:solidFill>
-                  <a:srgbClr val="FF0000"/>
-                </a:solidFill>
-              </a:rPr>
-              <a:t>n</a:t>
-            </a:r>
-            <a:r>
-              <a:rPr lang="da-DK" dirty="0" err="1"/>
-              <a:t>Priya</a:t>
-            </a:r>
-            <a:r>
-              <a:rPr lang="da-DK" dirty="0"/>
-              <a:t> </a:t>
-            </a:r>
-            <a:r>
-              <a:rPr lang="da-DK" dirty="0" err="1"/>
-              <a:t>Sharma</a:t>
-            </a:r>
-            <a:r>
-              <a:rPr lang="da-DK" dirty="0" err="1">
-                <a:solidFill>
-                  <a:srgbClr val="FF0000"/>
-                </a:solidFill>
-              </a:rPr>
-              <a:t>,</a:t>
-            </a:r>
-            <a:r>
-              <a:rPr lang="da-DK" dirty="0" err="1"/>
-              <a:t>priya.sharma@example.com</a:t>
-            </a:r>
-            <a:r>
-              <a:rPr lang="da-DK" dirty="0"/>
-              <a:t>”</a:t>
-            </a:r>
-          </a:p>
-          <a:p>
-            <a:pPr marL="0" indent="0">
-              <a:buNone/>
-            </a:pPr>
-            <a:endParaRPr lang="da-DK" dirty="0"/>
-          </a:p>
-          <a:p>
-            <a:r>
-              <a:rPr lang="da-DK" dirty="0"/>
-              <a:t>parser=Parser()</a:t>
-            </a:r>
-          </a:p>
-          <a:p>
-            <a:pPr lvl="1"/>
-            <a:r>
-              <a:rPr lang="da-DK" dirty="0"/>
-              <a:t>Husk betyder header=</a:t>
-            </a:r>
-            <a:r>
-              <a:rPr lang="da-DK" dirty="0" err="1"/>
-              <a:t>True,seperator</a:t>
-            </a:r>
-            <a:r>
-              <a:rPr lang="da-DK" dirty="0"/>
-              <a:t>=",", </a:t>
-            </a:r>
-            <a:r>
-              <a:rPr lang="da-DK" dirty="0" err="1"/>
-              <a:t>lineseperator</a:t>
-            </a:r>
-            <a:r>
-              <a:rPr lang="da-DK" dirty="0"/>
-              <a:t>=["\n","\r"], </a:t>
-            </a:r>
-            <a:r>
-              <a:rPr lang="da-DK" dirty="0" err="1"/>
-              <a:t>Json</a:t>
-            </a:r>
-            <a:r>
-              <a:rPr lang="da-DK" dirty="0"/>
-              <a:t>=False</a:t>
-            </a:r>
-          </a:p>
-          <a:p>
-            <a:pPr marL="457200" lvl="1" indent="0">
-              <a:buNone/>
-            </a:pPr>
-            <a:endParaRPr lang="da-DK" dirty="0"/>
-          </a:p>
-          <a:p>
-            <a:r>
-              <a:rPr lang="da-DK" dirty="0"/>
-              <a:t>Print(</a:t>
-            </a:r>
-            <a:r>
-              <a:rPr lang="da-DK" dirty="0" err="1"/>
-              <a:t>parser.parse</a:t>
-            </a:r>
-            <a:r>
-              <a:rPr lang="da-DK" dirty="0"/>
-              <a:t>(CSV))</a:t>
-            </a:r>
-          </a:p>
-          <a:p>
-            <a:pPr marL="0" indent="0">
-              <a:buNone/>
-            </a:pPr>
-            <a:endParaRPr lang="da-DK" dirty="0"/>
-          </a:p>
-          <a:p>
-            <a:pPr marL="0" indent="0">
-              <a:buNone/>
-            </a:pPr>
-            <a:r>
-              <a:rPr lang="da-DK" dirty="0"/>
-              <a:t>Output:</a:t>
-            </a:r>
-          </a:p>
-          <a:p>
-            <a:pPr marL="0" indent="0">
-              <a:buNone/>
-            </a:pPr>
-            <a:r>
-              <a:rPr lang="da-DK" dirty="0"/>
-              <a:t>[{'</a:t>
-            </a:r>
-            <a:r>
-              <a:rPr lang="da-DK" dirty="0" err="1"/>
-              <a:t>name</a:t>
-            </a:r>
-            <a:r>
-              <a:rPr lang="da-DK" dirty="0"/>
-              <a:t>': 'Marcus Chen', '</a:t>
-            </a:r>
-            <a:r>
-              <a:rPr lang="da-DK" dirty="0" err="1"/>
-              <a:t>email</a:t>
-            </a:r>
-            <a:r>
-              <a:rPr lang="da-DK" dirty="0"/>
-              <a:t>': 'marcus.chen@example.com'}, {'</a:t>
-            </a:r>
-            <a:r>
-              <a:rPr lang="da-DK" dirty="0" err="1"/>
-              <a:t>name</a:t>
-            </a:r>
-            <a:r>
-              <a:rPr lang="da-DK" dirty="0"/>
-              <a:t>': 'Priya Sharma', '</a:t>
-            </a:r>
-            <a:r>
-              <a:rPr lang="da-DK" dirty="0" err="1"/>
-              <a:t>email</a:t>
-            </a:r>
-            <a:r>
-              <a:rPr lang="da-DK" dirty="0"/>
-              <a:t>': 'priya.sharma@example.com'}]</a:t>
-            </a:r>
-          </a:p>
-          <a:p>
-            <a:endParaRPr lang="da-DK" dirty="0"/>
-          </a:p>
-          <a:p>
-            <a:endParaRPr lang="da-DK" dirty="0"/>
+        <p:spPr/>
+        <p:txBody>
+          <a:bodyPr/>
+          <a:lstStyle/>
+          <a:p>
+            <a:r>
+              <a:rPr lang="da-DK" dirty="0"/>
+              <a:t>Lave JSON formatering selv uden pakken JSON</a:t>
+            </a:r>
+          </a:p>
+          <a:p>
+            <a:r>
+              <a:rPr lang="da-DK" dirty="0"/>
+              <a:t>Lave bedre brugerinterface. Så brugeren bliver spurgt.</a:t>
+            </a:r>
+          </a:p>
+          <a:p>
+            <a:r>
+              <a:rPr lang="da-DK" dirty="0"/>
+              <a:t>Håndtere at kunne rette simple fejl selv. Eksempelvis trykfejl.</a:t>
+            </a:r>
           </a:p>
         </p:txBody>
       </p:sp>
     </p:spTree>
     <p:extLst>
       <p:ext uri="{BB962C8B-B14F-4D97-AF65-F5344CB8AC3E}">
-        <p14:creationId xmlns:p14="http://schemas.microsoft.com/office/powerpoint/2010/main" val="858502015"/>
+        <p14:creationId xmlns:p14="http://schemas.microsoft.com/office/powerpoint/2010/main" val="1447179391"/>
       </p:ext>
     </p:extLst>
   </p:cSld>
@@ -5595,7 +5706,7 @@
           <p:cNvPr id="2" name="Titel 1">
             <a:extLst>
               <a:ext uri="{FF2B5EF4-FFF2-40B4-BE49-F238E27FC236}">
-                <a16:creationId xmlns:a16="http://schemas.microsoft.com/office/drawing/2014/main" id="{6C535205-40D6-9ABF-9C84-3DAB9CA2C5C2}"/>
+                <a16:creationId xmlns:a16="http://schemas.microsoft.com/office/drawing/2014/main" id="{9C1E398C-F0D0-314D-801D-2091EA5CF68E}"/>
               </a:ext>
             </a:extLst>
           </p:cNvPr>
@@ -5606,39 +5717,34 @@
             <p:ph type="title"/>
           </p:nvPr>
         </p:nvSpPr>
-        <p:spPr/>
-        <p:txBody>
-          <a:bodyPr/>
-          <a:lstStyle/>
-          <a:p>
-            <a:r>
-              <a:rPr lang="da-DK" dirty="0"/>
-              <a:t>Demo af parser(ekstra)</a:t>
-            </a:r>
-          </a:p>
-        </p:txBody>
-      </p:sp>
-      <p:sp>
-        <p:nvSpPr>
-          <p:cNvPr id="3" name="Pladsholder til indhold 2">
-            <a:extLst>
-              <a:ext uri="{FF2B5EF4-FFF2-40B4-BE49-F238E27FC236}">
-                <a16:creationId xmlns:a16="http://schemas.microsoft.com/office/drawing/2014/main" id="{3B192A0B-CBE9-2D4C-6BD1-33C181DEDE99}"/>
-              </a:ext>
-            </a:extLst>
-          </p:cNvPr>
-          <p:cNvSpPr>
-            <a:spLocks noGrp="1"/>
-          </p:cNvSpPr>
-          <p:nvPr>
-            <p:ph idx="1"/>
-          </p:nvPr>
-        </p:nvSpPr>
-        <p:spPr/>
-        <p:txBody>
-          <a:bodyPr/>
-          <a:lstStyle/>
-          <a:p>
+        <p:spPr>
+          <a:xfrm>
+            <a:off x="454152" y="2475817"/>
+            <a:ext cx="10994136" cy="1540605"/>
+          </a:xfrm>
+        </p:spPr>
+        <p:txBody>
+          <a:bodyPr/>
+          <a:lstStyle/>
+          <a:p>
+            <a:pPr algn="ctr"/>
+            <a:r>
+              <a:rPr lang="da-DK" dirty="0"/>
+              <a:t>Spørgsmål?</a:t>
+            </a:r>
+            <a:br>
+              <a:rPr lang="da-DK" dirty="0"/>
+            </a:br>
+            <a:r>
+              <a:rPr lang="da-DK" dirty="0"/>
+              <a:t>(og feedback </a:t>
+            </a:r>
+            <a:r>
+              <a:rPr lang="da-DK" dirty="0">
+                <a:sym typeface="Wingdings" panose="05000000000000000000" pitchFamily="2" charset="2"/>
+              </a:rPr>
+              <a:t>)</a:t>
+            </a:r>
             <a:endParaRPr lang="da-DK" dirty="0"/>
           </a:p>
         </p:txBody>
@@ -5646,7 +5752,7 @@
     </p:spTree>
     <p:extLst>
       <p:ext uri="{BB962C8B-B14F-4D97-AF65-F5344CB8AC3E}">
-        <p14:creationId xmlns:p14="http://schemas.microsoft.com/office/powerpoint/2010/main" val="2606010687"/>
+        <p14:creationId xmlns:p14="http://schemas.microsoft.com/office/powerpoint/2010/main" val="2674936550"/>
       </p:ext>
     </p:extLst>
   </p:cSld>

</xml_diff>